<commit_message>
fix(pptx): keep table cell text unmirrored inside flipped groups (#65)
Factor the net-mirror text cancellation from render_shape into unmirror_text and
apply it to table cells around the cell centre. Extend the flipped-text fixture
with a table slide and add a regression test.

Claude-Session: https://claude.ai/code/session_01WPGucr2TUYsgYFqzbQRj3u
</commit_message>
<xml_diff>
--- a/examples/flipped-text.pptx
+++ b/examples/flipped-text.pptx
@@ -6,6 +6,7 @@
   </p:sldMasterIdLst>
   <p:sldIdLst>
     <p:sldId id="256" r:id="rId7"/>
+    <p:sldId id="257" r:id="rId8"/>
   </p:sldIdLst>
   <p:sldSz cx="9144000" cy="5143500" type="screen4x3"/>
   <p:notesSz cx="6858000" cy="9144000"/>
@@ -3519,6 +3520,348 @@
           <p:spPr>
             <a:xfrm>
               <a:off x="6812280" y="3931920"/>
+              <a:ext cx="274320" cy="274320"/>
+            </a:xfrm>
+            <a:prstGeom prst="rect">
+              <a:avLst/>
+            </a:prstGeom>
+            <a:solidFill>
+              <a:srgbClr val="202020"/>
+            </a:solidFill>
+            <a:ln>
+              <a:noFill/>
+            </a:ln>
+          </p:spPr>
+          <p:txBody>
+            <a:bodyPr rtlCol="0" anchor="ctr"/>
+            <a:lstStyle/>
+            <a:p>
+              <a:pPr algn="ctr"/>
+            </a:p>
+          </p:txBody>
+        </p:sp>
+      </p:grpSp>
+    </p:spTree>
+  </p:cSld>
+  <p:clrMapOvr>
+    <a:masterClrMapping/>
+  </p:clrMapOvr>
+</p:sld>
+</file>
+
+<file path=ppt/slides/slide2.xml><?xml version="1.0" encoding="utf-8"?>
+<p:sld xmlns:a="http://schemas.openxmlformats.org/drawingml/2006/main" xmlns:p="http://schemas.openxmlformats.org/presentationml/2006/main" xmlns:r="http://schemas.openxmlformats.org/officeDocument/2006/relationships">
+  <p:cSld>
+    <p:spTree>
+      <p:nvGrpSpPr>
+        <p:cNvPr id="1" name=""/>
+        <p:cNvGrpSpPr/>
+        <p:nvPr/>
+      </p:nvGrpSpPr>
+      <p:grpSpPr/>
+      <p:graphicFrame>
+        <p:nvGraphicFramePr>
+          <p:cNvPr id="2" name="Table 1"/>
+          <p:cNvGraphicFramePr>
+            <a:graphicFrameLocks noGrp="1"/>
+          </p:cNvGraphicFramePr>
+          <p:nvPr/>
+        </p:nvGraphicFramePr>
+        <p:xfrm>
+          <a:off x="365760" y="457200"/>
+          <a:ext cx="1828800" cy="1280160"/>
+        </p:xfrm>
+        <a:graphic>
+          <a:graphicData uri="http://schemas.openxmlformats.org/drawingml/2006/table">
+            <a:tbl>
+              <a:tblPr/>
+              <a:tblGrid>
+                <a:gridCol w="1828800"/>
+              </a:tblGrid>
+              <a:tr h="1280160">
+                <a:tc>
+                  <a:txBody>
+                    <a:bodyPr/>
+                    <a:lstStyle/>
+                    <a:p>
+                      <a:pPr algn="l"/>
+                      <a:r>
+                        <a:rPr sz="2000">
+                          <a:solidFill>
+                            <a:srgbClr val="000000"/>
+                          </a:solidFill>
+                          <a:latin typeface="Arial"/>
+                        </a:rPr>
+                        <a:t>Rk 1 table</a:t>
+                      </a:r>
+                    </a:p>
+                  </a:txBody>
+                  <a:tcPr anchor="t">
+                    <a:solidFill>
+                      <a:srgbClr val="FFE699"/>
+                    </a:solidFill>
+                  </a:tcPr>
+                </a:tc>
+              </a:tr>
+            </a:tbl>
+          </a:graphicData>
+        </a:graphic>
+      </p:graphicFrame>
+      <p:grpSp>
+        <p:nvGrpSpPr>
+          <p:cNvPr id="4" name="Group 3"/>
+          <p:cNvGrpSpPr/>
+          <p:nvPr/>
+        </p:nvGrpSpPr>
+        <p:grpSpPr>
+          <a:xfrm flipH="1">
+            <a:off x="2514600" y="457200"/>
+            <a:ext cx="1828800" cy="1280160"/>
+            <a:chOff x="2514600" y="457200"/>
+            <a:chExt cx="1828800" cy="1280160"/>
+          </a:xfrm>
+        </p:grpSpPr>
+        <p:graphicFrame>
+          <p:nvGraphicFramePr>
+            <p:cNvPr id="3" name="Table 2"/>
+            <p:cNvGraphicFramePr>
+              <a:graphicFrameLocks noGrp="1"/>
+            </p:cNvGraphicFramePr>
+            <p:nvPr/>
+          </p:nvGraphicFramePr>
+          <p:xfrm>
+            <a:off x="2514600" y="457200"/>
+            <a:ext cx="1828800" cy="1280160"/>
+          </p:xfrm>
+          <a:graphic>
+            <a:graphicData uri="http://schemas.openxmlformats.org/drawingml/2006/table">
+              <a:tbl>
+                <a:tblPr/>
+                <a:tblGrid>
+                  <a:gridCol w="1828800"/>
+                </a:tblGrid>
+                <a:tr h="1280160">
+                  <a:tc>
+                    <a:txBody>
+                      <a:bodyPr/>
+                      <a:lstStyle/>
+                      <a:p>
+                        <a:pPr algn="l"/>
+                        <a:r>
+                          <a:rPr sz="2000">
+                            <a:solidFill>
+                              <a:srgbClr val="000000"/>
+                            </a:solidFill>
+                            <a:latin typeface="Arial"/>
+                          </a:rPr>
+                          <a:t>Rk 2 grpH</a:t>
+                        </a:r>
+                      </a:p>
+                    </a:txBody>
+                    <a:tcPr anchor="t">
+                      <a:solidFill>
+                        <a:srgbClr val="FFE699"/>
+                      </a:solidFill>
+                    </a:tcPr>
+                  </a:tc>
+                </a:tr>
+              </a:tbl>
+            </a:graphicData>
+          </a:graphic>
+        </p:graphicFrame>
+        <p:sp>
+          <p:nvSpPr>
+            <p:cNvPr id="5" name="Rectangle 4"/>
+            <p:cNvSpPr/>
+            <p:nvPr/>
+          </p:nvSpPr>
+          <p:spPr>
+            <a:xfrm>
+              <a:off x="2514600" y="1463040"/>
+              <a:ext cx="274320" cy="274320"/>
+            </a:xfrm>
+            <a:prstGeom prst="rect">
+              <a:avLst/>
+            </a:prstGeom>
+            <a:solidFill>
+              <a:srgbClr val="202020"/>
+            </a:solidFill>
+            <a:ln>
+              <a:noFill/>
+            </a:ln>
+          </p:spPr>
+          <p:txBody>
+            <a:bodyPr rtlCol="0" anchor="ctr"/>
+            <a:lstStyle/>
+            <a:p>
+              <a:pPr algn="ctr"/>
+            </a:p>
+          </p:txBody>
+        </p:sp>
+      </p:grpSp>
+      <p:grpSp>
+        <p:nvGrpSpPr>
+          <p:cNvPr id="7" name="Group 6"/>
+          <p:cNvGrpSpPr/>
+          <p:nvPr/>
+        </p:nvGrpSpPr>
+        <p:grpSpPr>
+          <a:xfrm flipV="1">
+            <a:off x="4663440" y="457200"/>
+            <a:ext cx="1828800" cy="1280160"/>
+            <a:chOff x="4663440" y="457200"/>
+            <a:chExt cx="1828800" cy="1280160"/>
+          </a:xfrm>
+        </p:grpSpPr>
+        <p:graphicFrame>
+          <p:nvGraphicFramePr>
+            <p:cNvPr id="6" name="Table 5"/>
+            <p:cNvGraphicFramePr>
+              <a:graphicFrameLocks noGrp="1"/>
+            </p:cNvGraphicFramePr>
+            <p:nvPr/>
+          </p:nvGraphicFramePr>
+          <p:xfrm>
+            <a:off x="4663440" y="457200"/>
+            <a:ext cx="1828800" cy="1280160"/>
+          </p:xfrm>
+          <a:graphic>
+            <a:graphicData uri="http://schemas.openxmlformats.org/drawingml/2006/table">
+              <a:tbl>
+                <a:tblPr/>
+                <a:tblGrid>
+                  <a:gridCol w="1828800"/>
+                </a:tblGrid>
+                <a:tr h="1280160">
+                  <a:tc>
+                    <a:txBody>
+                      <a:bodyPr/>
+                      <a:lstStyle/>
+                      <a:p>
+                        <a:pPr algn="l"/>
+                        <a:r>
+                          <a:rPr sz="2000">
+                            <a:solidFill>
+                              <a:srgbClr val="000000"/>
+                            </a:solidFill>
+                            <a:latin typeface="Arial"/>
+                          </a:rPr>
+                          <a:t>Rk 3 grpV</a:t>
+                        </a:r>
+                      </a:p>
+                    </a:txBody>
+                    <a:tcPr anchor="t">
+                      <a:solidFill>
+                        <a:srgbClr val="FFE699"/>
+                      </a:solidFill>
+                    </a:tcPr>
+                  </a:tc>
+                </a:tr>
+              </a:tbl>
+            </a:graphicData>
+          </a:graphic>
+        </p:graphicFrame>
+        <p:sp>
+          <p:nvSpPr>
+            <p:cNvPr id="8" name="Rectangle 7"/>
+            <p:cNvSpPr/>
+            <p:nvPr/>
+          </p:nvSpPr>
+          <p:spPr>
+            <a:xfrm>
+              <a:off x="4663440" y="1463040"/>
+              <a:ext cx="274320" cy="274320"/>
+            </a:xfrm>
+            <a:prstGeom prst="rect">
+              <a:avLst/>
+            </a:prstGeom>
+            <a:solidFill>
+              <a:srgbClr val="202020"/>
+            </a:solidFill>
+            <a:ln>
+              <a:noFill/>
+            </a:ln>
+          </p:spPr>
+          <p:txBody>
+            <a:bodyPr rtlCol="0" anchor="ctr"/>
+            <a:lstStyle/>
+            <a:p>
+              <a:pPr algn="ctr"/>
+            </a:p>
+          </p:txBody>
+        </p:sp>
+      </p:grpSp>
+      <p:grpSp>
+        <p:nvGrpSpPr>
+          <p:cNvPr id="10" name="Group 9"/>
+          <p:cNvGrpSpPr/>
+          <p:nvPr/>
+        </p:nvGrpSpPr>
+        <p:grpSpPr>
+          <a:xfrm flipH="1" flipV="1">
+            <a:off x="6812280" y="457200"/>
+            <a:ext cx="1828800" cy="1280160"/>
+            <a:chOff x="6812280" y="457200"/>
+            <a:chExt cx="1828800" cy="1280160"/>
+          </a:xfrm>
+        </p:grpSpPr>
+        <p:graphicFrame>
+          <p:nvGraphicFramePr>
+            <p:cNvPr id="9" name="Table 8"/>
+            <p:cNvGraphicFramePr>
+              <a:graphicFrameLocks noGrp="1"/>
+            </p:cNvGraphicFramePr>
+            <p:nvPr/>
+          </p:nvGraphicFramePr>
+          <p:xfrm>
+            <a:off x="6812280" y="457200"/>
+            <a:ext cx="1828800" cy="1280160"/>
+          </p:xfrm>
+          <a:graphic>
+            <a:graphicData uri="http://schemas.openxmlformats.org/drawingml/2006/table">
+              <a:tbl>
+                <a:tblPr/>
+                <a:tblGrid>
+                  <a:gridCol w="1828800"/>
+                </a:tblGrid>
+                <a:tr h="1280160">
+                  <a:tc>
+                    <a:txBody>
+                      <a:bodyPr/>
+                      <a:lstStyle/>
+                      <a:p>
+                        <a:pPr algn="l"/>
+                        <a:r>
+                          <a:rPr sz="2000">
+                            <a:solidFill>
+                              <a:srgbClr val="000000"/>
+                            </a:solidFill>
+                            <a:latin typeface="Arial"/>
+                          </a:rPr>
+                          <a:t>Rk 4 grpHV</a:t>
+                        </a:r>
+                      </a:p>
+                    </a:txBody>
+                    <a:tcPr anchor="t">
+                      <a:solidFill>
+                        <a:srgbClr val="FFE699"/>
+                      </a:solidFill>
+                    </a:tcPr>
+                  </a:tc>
+                </a:tr>
+              </a:tbl>
+            </a:graphicData>
+          </a:graphic>
+        </p:graphicFrame>
+        <p:sp>
+          <p:nvSpPr>
+            <p:cNvPr id="11" name="Rectangle 10"/>
+            <p:cNvSpPr/>
+            <p:nvPr/>
+          </p:nvSpPr>
+          <p:spPr>
+            <a:xfrm>
+              <a:off x="6812280" y="1463040"/>
               <a:ext cx="274320" cy="274320"/>
             </a:xfrm>
             <a:prstGeom prst="rect">

</xml_diff>

<commit_message>
fix(pptx): keep table cell text unmirrored inside flipped groups (#65) (#68)
Factor the net-mirror text cancellation from render_shape into unmirror_text and
apply it to table cells around the cell centre. Extend the flipped-text fixture
with a table slide and add a regression test.

Claude-Session: https://claude.ai/code/session_01WPGucr2TUYsgYFqzbQRj3u
</commit_message>
<xml_diff>
--- a/examples/flipped-text.pptx
+++ b/examples/flipped-text.pptx
@@ -6,6 +6,7 @@
   </p:sldMasterIdLst>
   <p:sldIdLst>
     <p:sldId id="256" r:id="rId7"/>
+    <p:sldId id="257" r:id="rId8"/>
   </p:sldIdLst>
   <p:sldSz cx="9144000" cy="5143500" type="screen4x3"/>
   <p:notesSz cx="6858000" cy="9144000"/>
@@ -3519,6 +3520,348 @@
           <p:spPr>
             <a:xfrm>
               <a:off x="6812280" y="3931920"/>
+              <a:ext cx="274320" cy="274320"/>
+            </a:xfrm>
+            <a:prstGeom prst="rect">
+              <a:avLst/>
+            </a:prstGeom>
+            <a:solidFill>
+              <a:srgbClr val="202020"/>
+            </a:solidFill>
+            <a:ln>
+              <a:noFill/>
+            </a:ln>
+          </p:spPr>
+          <p:txBody>
+            <a:bodyPr rtlCol="0" anchor="ctr"/>
+            <a:lstStyle/>
+            <a:p>
+              <a:pPr algn="ctr"/>
+            </a:p>
+          </p:txBody>
+        </p:sp>
+      </p:grpSp>
+    </p:spTree>
+  </p:cSld>
+  <p:clrMapOvr>
+    <a:masterClrMapping/>
+  </p:clrMapOvr>
+</p:sld>
+</file>
+
+<file path=ppt/slides/slide2.xml><?xml version="1.0" encoding="utf-8"?>
+<p:sld xmlns:a="http://schemas.openxmlformats.org/drawingml/2006/main" xmlns:p="http://schemas.openxmlformats.org/presentationml/2006/main" xmlns:r="http://schemas.openxmlformats.org/officeDocument/2006/relationships">
+  <p:cSld>
+    <p:spTree>
+      <p:nvGrpSpPr>
+        <p:cNvPr id="1" name=""/>
+        <p:cNvGrpSpPr/>
+        <p:nvPr/>
+      </p:nvGrpSpPr>
+      <p:grpSpPr/>
+      <p:graphicFrame>
+        <p:nvGraphicFramePr>
+          <p:cNvPr id="2" name="Table 1"/>
+          <p:cNvGraphicFramePr>
+            <a:graphicFrameLocks noGrp="1"/>
+          </p:cNvGraphicFramePr>
+          <p:nvPr/>
+        </p:nvGraphicFramePr>
+        <p:xfrm>
+          <a:off x="365760" y="457200"/>
+          <a:ext cx="1828800" cy="1280160"/>
+        </p:xfrm>
+        <a:graphic>
+          <a:graphicData uri="http://schemas.openxmlformats.org/drawingml/2006/table">
+            <a:tbl>
+              <a:tblPr/>
+              <a:tblGrid>
+                <a:gridCol w="1828800"/>
+              </a:tblGrid>
+              <a:tr h="1280160">
+                <a:tc>
+                  <a:txBody>
+                    <a:bodyPr/>
+                    <a:lstStyle/>
+                    <a:p>
+                      <a:pPr algn="l"/>
+                      <a:r>
+                        <a:rPr sz="2000">
+                          <a:solidFill>
+                            <a:srgbClr val="000000"/>
+                          </a:solidFill>
+                          <a:latin typeface="Arial"/>
+                        </a:rPr>
+                        <a:t>Rk 1 table</a:t>
+                      </a:r>
+                    </a:p>
+                  </a:txBody>
+                  <a:tcPr anchor="t">
+                    <a:solidFill>
+                      <a:srgbClr val="FFE699"/>
+                    </a:solidFill>
+                  </a:tcPr>
+                </a:tc>
+              </a:tr>
+            </a:tbl>
+          </a:graphicData>
+        </a:graphic>
+      </p:graphicFrame>
+      <p:grpSp>
+        <p:nvGrpSpPr>
+          <p:cNvPr id="4" name="Group 3"/>
+          <p:cNvGrpSpPr/>
+          <p:nvPr/>
+        </p:nvGrpSpPr>
+        <p:grpSpPr>
+          <a:xfrm flipH="1">
+            <a:off x="2514600" y="457200"/>
+            <a:ext cx="1828800" cy="1280160"/>
+            <a:chOff x="2514600" y="457200"/>
+            <a:chExt cx="1828800" cy="1280160"/>
+          </a:xfrm>
+        </p:grpSpPr>
+        <p:graphicFrame>
+          <p:nvGraphicFramePr>
+            <p:cNvPr id="3" name="Table 2"/>
+            <p:cNvGraphicFramePr>
+              <a:graphicFrameLocks noGrp="1"/>
+            </p:cNvGraphicFramePr>
+            <p:nvPr/>
+          </p:nvGraphicFramePr>
+          <p:xfrm>
+            <a:off x="2514600" y="457200"/>
+            <a:ext cx="1828800" cy="1280160"/>
+          </p:xfrm>
+          <a:graphic>
+            <a:graphicData uri="http://schemas.openxmlformats.org/drawingml/2006/table">
+              <a:tbl>
+                <a:tblPr/>
+                <a:tblGrid>
+                  <a:gridCol w="1828800"/>
+                </a:tblGrid>
+                <a:tr h="1280160">
+                  <a:tc>
+                    <a:txBody>
+                      <a:bodyPr/>
+                      <a:lstStyle/>
+                      <a:p>
+                        <a:pPr algn="l"/>
+                        <a:r>
+                          <a:rPr sz="2000">
+                            <a:solidFill>
+                              <a:srgbClr val="000000"/>
+                            </a:solidFill>
+                            <a:latin typeface="Arial"/>
+                          </a:rPr>
+                          <a:t>Rk 2 grpH</a:t>
+                        </a:r>
+                      </a:p>
+                    </a:txBody>
+                    <a:tcPr anchor="t">
+                      <a:solidFill>
+                        <a:srgbClr val="FFE699"/>
+                      </a:solidFill>
+                    </a:tcPr>
+                  </a:tc>
+                </a:tr>
+              </a:tbl>
+            </a:graphicData>
+          </a:graphic>
+        </p:graphicFrame>
+        <p:sp>
+          <p:nvSpPr>
+            <p:cNvPr id="5" name="Rectangle 4"/>
+            <p:cNvSpPr/>
+            <p:nvPr/>
+          </p:nvSpPr>
+          <p:spPr>
+            <a:xfrm>
+              <a:off x="2514600" y="1463040"/>
+              <a:ext cx="274320" cy="274320"/>
+            </a:xfrm>
+            <a:prstGeom prst="rect">
+              <a:avLst/>
+            </a:prstGeom>
+            <a:solidFill>
+              <a:srgbClr val="202020"/>
+            </a:solidFill>
+            <a:ln>
+              <a:noFill/>
+            </a:ln>
+          </p:spPr>
+          <p:txBody>
+            <a:bodyPr rtlCol="0" anchor="ctr"/>
+            <a:lstStyle/>
+            <a:p>
+              <a:pPr algn="ctr"/>
+            </a:p>
+          </p:txBody>
+        </p:sp>
+      </p:grpSp>
+      <p:grpSp>
+        <p:nvGrpSpPr>
+          <p:cNvPr id="7" name="Group 6"/>
+          <p:cNvGrpSpPr/>
+          <p:nvPr/>
+        </p:nvGrpSpPr>
+        <p:grpSpPr>
+          <a:xfrm flipV="1">
+            <a:off x="4663440" y="457200"/>
+            <a:ext cx="1828800" cy="1280160"/>
+            <a:chOff x="4663440" y="457200"/>
+            <a:chExt cx="1828800" cy="1280160"/>
+          </a:xfrm>
+        </p:grpSpPr>
+        <p:graphicFrame>
+          <p:nvGraphicFramePr>
+            <p:cNvPr id="6" name="Table 5"/>
+            <p:cNvGraphicFramePr>
+              <a:graphicFrameLocks noGrp="1"/>
+            </p:cNvGraphicFramePr>
+            <p:nvPr/>
+          </p:nvGraphicFramePr>
+          <p:xfrm>
+            <a:off x="4663440" y="457200"/>
+            <a:ext cx="1828800" cy="1280160"/>
+          </p:xfrm>
+          <a:graphic>
+            <a:graphicData uri="http://schemas.openxmlformats.org/drawingml/2006/table">
+              <a:tbl>
+                <a:tblPr/>
+                <a:tblGrid>
+                  <a:gridCol w="1828800"/>
+                </a:tblGrid>
+                <a:tr h="1280160">
+                  <a:tc>
+                    <a:txBody>
+                      <a:bodyPr/>
+                      <a:lstStyle/>
+                      <a:p>
+                        <a:pPr algn="l"/>
+                        <a:r>
+                          <a:rPr sz="2000">
+                            <a:solidFill>
+                              <a:srgbClr val="000000"/>
+                            </a:solidFill>
+                            <a:latin typeface="Arial"/>
+                          </a:rPr>
+                          <a:t>Rk 3 grpV</a:t>
+                        </a:r>
+                      </a:p>
+                    </a:txBody>
+                    <a:tcPr anchor="t">
+                      <a:solidFill>
+                        <a:srgbClr val="FFE699"/>
+                      </a:solidFill>
+                    </a:tcPr>
+                  </a:tc>
+                </a:tr>
+              </a:tbl>
+            </a:graphicData>
+          </a:graphic>
+        </p:graphicFrame>
+        <p:sp>
+          <p:nvSpPr>
+            <p:cNvPr id="8" name="Rectangle 7"/>
+            <p:cNvSpPr/>
+            <p:nvPr/>
+          </p:nvSpPr>
+          <p:spPr>
+            <a:xfrm>
+              <a:off x="4663440" y="1463040"/>
+              <a:ext cx="274320" cy="274320"/>
+            </a:xfrm>
+            <a:prstGeom prst="rect">
+              <a:avLst/>
+            </a:prstGeom>
+            <a:solidFill>
+              <a:srgbClr val="202020"/>
+            </a:solidFill>
+            <a:ln>
+              <a:noFill/>
+            </a:ln>
+          </p:spPr>
+          <p:txBody>
+            <a:bodyPr rtlCol="0" anchor="ctr"/>
+            <a:lstStyle/>
+            <a:p>
+              <a:pPr algn="ctr"/>
+            </a:p>
+          </p:txBody>
+        </p:sp>
+      </p:grpSp>
+      <p:grpSp>
+        <p:nvGrpSpPr>
+          <p:cNvPr id="10" name="Group 9"/>
+          <p:cNvGrpSpPr/>
+          <p:nvPr/>
+        </p:nvGrpSpPr>
+        <p:grpSpPr>
+          <a:xfrm flipH="1" flipV="1">
+            <a:off x="6812280" y="457200"/>
+            <a:ext cx="1828800" cy="1280160"/>
+            <a:chOff x="6812280" y="457200"/>
+            <a:chExt cx="1828800" cy="1280160"/>
+          </a:xfrm>
+        </p:grpSpPr>
+        <p:graphicFrame>
+          <p:nvGraphicFramePr>
+            <p:cNvPr id="9" name="Table 8"/>
+            <p:cNvGraphicFramePr>
+              <a:graphicFrameLocks noGrp="1"/>
+            </p:cNvGraphicFramePr>
+            <p:nvPr/>
+          </p:nvGraphicFramePr>
+          <p:xfrm>
+            <a:off x="6812280" y="457200"/>
+            <a:ext cx="1828800" cy="1280160"/>
+          </p:xfrm>
+          <a:graphic>
+            <a:graphicData uri="http://schemas.openxmlformats.org/drawingml/2006/table">
+              <a:tbl>
+                <a:tblPr/>
+                <a:tblGrid>
+                  <a:gridCol w="1828800"/>
+                </a:tblGrid>
+                <a:tr h="1280160">
+                  <a:tc>
+                    <a:txBody>
+                      <a:bodyPr/>
+                      <a:lstStyle/>
+                      <a:p>
+                        <a:pPr algn="l"/>
+                        <a:r>
+                          <a:rPr sz="2000">
+                            <a:solidFill>
+                              <a:srgbClr val="000000"/>
+                            </a:solidFill>
+                            <a:latin typeface="Arial"/>
+                          </a:rPr>
+                          <a:t>Rk 4 grpHV</a:t>
+                        </a:r>
+                      </a:p>
+                    </a:txBody>
+                    <a:tcPr anchor="t">
+                      <a:solidFill>
+                        <a:srgbClr val="FFE699"/>
+                      </a:solidFill>
+                    </a:tcPr>
+                  </a:tc>
+                </a:tr>
+              </a:tbl>
+            </a:graphicData>
+          </a:graphic>
+        </p:graphicFrame>
+        <p:sp>
+          <p:nvSpPr>
+            <p:cNvPr id="11" name="Rectangle 10"/>
+            <p:cNvSpPr/>
+            <p:nvPr/>
+          </p:nvSpPr>
+          <p:spPr>
+            <a:xfrm>
+              <a:off x="6812280" y="1463040"/>
               <a:ext cx="274320" cy="274320"/>
             </a:xfrm>
             <a:prstGeom prst="rect">

</xml_diff>